<commit_message>
[2026-06-26 22:34] add PPT COM automation plan, update launch config and PPT template
</commit_message>
<xml_diff>
--- a/res/PPTTemplate/Template.pptx
+++ b/res/PPTTemplate/Template.pptx
@@ -17768,7 +17768,7 @@
         <p:spPr>
           <a:xfrm>
             <a:off x="12673440" y="1272978"/>
-            <a:ext cx="6530634" cy="1087477"/>
+            <a:ext cx="1987724" cy="1087477"/>
           </a:xfrm>
           <a:prstGeom prst="rect">
             <a:avLst/>
@@ -17801,7 +17801,7 @@
               <a:defRPr/>
             </a:pPr>
             <a:r>
-              <a:rPr lang="en-US" altLang="zh-CN" sz="6400" dirty="0">
+              <a:rPr lang="en-US" altLang="zh-CN" sz="6400">
                 <a:solidFill>
                   <a:srgbClr val="434343">
                     <a:lumMod val="50000"/>
@@ -17810,8 +17810,17 @@
                 <a:latin typeface="Meiryo UI" panose="020B0604030504040204" pitchFamily="34" charset="-128"/>
                 <a:ea typeface="Meiryo UI" panose="020B0604030504040204" pitchFamily="34" charset="-128"/>
               </a:rPr>
-              <a:t>Self Test Report</a:t>
-            </a:r>
+              <a:t>DIFF</a:t>
+            </a:r>
+            <a:endParaRPr lang="en-US" altLang="zh-CN" sz="6400" dirty="0">
+              <a:solidFill>
+                <a:srgbClr val="434343">
+                  <a:lumMod val="50000"/>
+                </a:srgbClr>
+              </a:solidFill>
+              <a:latin typeface="Meiryo UI" panose="020B0604030504040204" pitchFamily="34" charset="-128"/>
+              <a:ea typeface="Meiryo UI" panose="020B0604030504040204" pitchFamily="34" charset="-128"/>
+            </a:endParaRPr>
           </a:p>
         </p:txBody>
       </p:sp>

</xml_diff>